<commit_message>
update divide and conquer method presentation
</commit_message>
<xml_diff>
--- a/Data-structures-and-algorithms/Presentations/source/divide-and-conquer.pptx
+++ b/Data-structures-and-algorithms/Presentations/source/divide-and-conquer.pptx
@@ -9,11 +9,14 @@
     <p:sldId id="259" r:id="rId3"/>
     <p:sldId id="257" r:id="rId4"/>
     <p:sldId id="267" r:id="rId5"/>
-    <p:sldId id="268" r:id="rId6"/>
+    <p:sldId id="270" r:id="rId6"/>
     <p:sldId id="271" r:id="rId7"/>
-    <p:sldId id="270" r:id="rId8"/>
-    <p:sldId id="269" r:id="rId9"/>
-    <p:sldId id="266" r:id="rId10"/>
+    <p:sldId id="273" r:id="rId8"/>
+    <p:sldId id="272" r:id="rId9"/>
+    <p:sldId id="274" r:id="rId10"/>
+    <p:sldId id="268" r:id="rId11"/>
+    <p:sldId id="269" r:id="rId12"/>
+    <p:sldId id="266" r:id="rId13"/>
   </p:sldIdLst>
   <p:sldSz cx="12192000" cy="6858000"/>
   <p:notesSz cx="6858000" cy="9144000"/>
@@ -290,7 +293,7 @@
             <a:fld id="{87DE6118-2437-4B30-8E3C-4D2BE6020583}" type="datetimeFigureOut">
               <a:rPr lang="en-US" dirty="0"/>
               <a:pPr/>
-              <a:t>3/23/2026</a:t>
+              <a:t>3/29/2026</a:t>
             </a:fld>
             <a:endParaRPr lang="en-US" dirty="0"/>
           </a:p>
@@ -616,7 +619,7 @@
           <a:p>
             <a:fld id="{87DE6118-2437-4B30-8E3C-4D2BE6020583}" type="datetimeFigureOut">
               <a:rPr lang="en-US" dirty="0"/>
-              <a:t>3/23/2026</a:t>
+              <a:t>3/29/2026</a:t>
             </a:fld>
             <a:endParaRPr lang="en-US" dirty="0"/>
           </a:p>
@@ -791,7 +794,7 @@
           <a:p>
             <a:fld id="{87DE6118-2437-4B30-8E3C-4D2BE6020583}" type="datetimeFigureOut">
               <a:rPr lang="en-US" dirty="0"/>
-              <a:t>3/23/2026</a:t>
+              <a:t>3/29/2026</a:t>
             </a:fld>
             <a:endParaRPr lang="en-US" dirty="0"/>
           </a:p>
@@ -956,7 +959,7 @@
           <a:p>
             <a:fld id="{87DE6118-2437-4B30-8E3C-4D2BE6020583}" type="datetimeFigureOut">
               <a:rPr lang="en-US" dirty="0"/>
-              <a:t>3/23/2026</a:t>
+              <a:t>3/29/2026</a:t>
             </a:fld>
             <a:endParaRPr lang="en-US" dirty="0"/>
           </a:p>
@@ -1229,7 +1232,7 @@
             <a:fld id="{87DE6118-2437-4B30-8E3C-4D2BE6020583}" type="datetimeFigureOut">
               <a:rPr lang="en-US" dirty="0"/>
               <a:pPr/>
-              <a:t>3/23/2026</a:t>
+              <a:t>3/29/2026</a:t>
             </a:fld>
             <a:endParaRPr lang="en-US" dirty="0"/>
           </a:p>
@@ -1619,7 +1622,7 @@
           <a:p>
             <a:fld id="{87DE6118-2437-4B30-8E3C-4D2BE6020583}" type="datetimeFigureOut">
               <a:rPr lang="en-US" dirty="0"/>
-              <a:t>3/23/2026</a:t>
+              <a:t>3/29/2026</a:t>
             </a:fld>
             <a:endParaRPr lang="en-US" dirty="0"/>
           </a:p>
@@ -2091,7 +2094,7 @@
           <a:p>
             <a:fld id="{87DE6118-2437-4B30-8E3C-4D2BE6020583}" type="datetimeFigureOut">
               <a:rPr lang="en-US" dirty="0"/>
-              <a:t>3/23/2026</a:t>
+              <a:t>3/29/2026</a:t>
             </a:fld>
             <a:endParaRPr lang="en-US" dirty="0"/>
           </a:p>
@@ -2204,7 +2207,7 @@
           <a:p>
             <a:fld id="{87DE6118-2437-4B30-8E3C-4D2BE6020583}" type="datetimeFigureOut">
               <a:rPr lang="en-US" dirty="0"/>
-              <a:t>3/23/2026</a:t>
+              <a:t>3/29/2026</a:t>
             </a:fld>
             <a:endParaRPr lang="en-US" dirty="0"/>
           </a:p>
@@ -2294,7 +2297,7 @@
           <a:p>
             <a:fld id="{87DE6118-2437-4B30-8E3C-4D2BE6020583}" type="datetimeFigureOut">
               <a:rPr lang="en-US" dirty="0"/>
-              <a:t>3/23/2026</a:t>
+              <a:t>3/29/2026</a:t>
             </a:fld>
             <a:endParaRPr lang="en-US" dirty="0"/>
           </a:p>
@@ -2636,7 +2639,7 @@
             <a:fld id="{87DE6118-2437-4B30-8E3C-4D2BE6020583}" type="datetimeFigureOut">
               <a:rPr lang="en-US" dirty="0"/>
               <a:pPr/>
-              <a:t>3/23/2026</a:t>
+              <a:t>3/29/2026</a:t>
             </a:fld>
             <a:endParaRPr lang="en-US" dirty="0"/>
           </a:p>
@@ -3021,7 +3024,7 @@
             <a:fld id="{87DE6118-2437-4B30-8E3C-4D2BE6020583}" type="datetimeFigureOut">
               <a:rPr lang="en-US" dirty="0"/>
               <a:pPr/>
-              <a:t>3/23/2026</a:t>
+              <a:t>3/29/2026</a:t>
             </a:fld>
             <a:endParaRPr lang="en-US" dirty="0"/>
           </a:p>
@@ -3296,7 +3299,7 @@
             <a:fld id="{87DE6118-2437-4B30-8E3C-4D2BE6020583}" type="datetimeFigureOut">
               <a:rPr lang="en-US" dirty="0"/>
               <a:pPr/>
-              <a:t>3/23/2026</a:t>
+              <a:t>3/29/2026</a:t>
             </a:fld>
             <a:endParaRPr lang="en-US" dirty="0"/>
           </a:p>
@@ -4091,6 +4094,337 @@
 </p:sld>
 </file>
 
+<file path=ppt/slides/slide10.xml><?xml version="1.0" encoding="utf-8"?>
+<p:sld xmlns:a="http://schemas.openxmlformats.org/drawingml/2006/main" xmlns:r="http://schemas.openxmlformats.org/officeDocument/2006/relationships" xmlns:p="http://schemas.openxmlformats.org/presentationml/2006/main">
+  <p:cSld>
+    <p:bg>
+      <p:bgPr>
+        <a:solidFill>
+          <a:schemeClr val="bg1"/>
+        </a:solidFill>
+        <a:effectLst/>
+      </p:bgPr>
+    </p:bg>
+    <p:spTree>
+      <p:nvGrpSpPr>
+        <p:cNvPr id="1" name=""/>
+        <p:cNvGrpSpPr/>
+        <p:nvPr/>
+      </p:nvGrpSpPr>
+      <p:grpSpPr>
+        <a:xfrm>
+          <a:off x="0" y="0"/>
+          <a:ext cx="0" cy="0"/>
+          <a:chOff x="0" y="0"/>
+          <a:chExt cx="0" cy="0"/>
+        </a:xfrm>
+      </p:grpSpPr>
+      <p:pic>
+        <p:nvPicPr>
+          <p:cNvPr id="5" name="Рисунок 4">
+            <a:extLst>
+              <a:ext uri="{FF2B5EF4-FFF2-40B4-BE49-F238E27FC236}">
+                <a16:creationId xmlns:a16="http://schemas.microsoft.com/office/drawing/2014/main" id="{479EB046-F122-4400-FBF1-534468400E34}"/>
+              </a:ext>
+            </a:extLst>
+          </p:cNvPr>
+          <p:cNvPicPr>
+            <a:picLocks noChangeAspect="1"/>
+          </p:cNvPicPr>
+          <p:nvPr/>
+        </p:nvPicPr>
+        <p:blipFill>
+          <a:blip r:embed="rId2"/>
+          <a:srcRect t="6316"/>
+          <a:stretch/>
+        </p:blipFill>
+        <p:spPr>
+          <a:xfrm>
+            <a:off x="1349908" y="952808"/>
+            <a:ext cx="10254184" cy="5690938"/>
+          </a:xfrm>
+          <a:prstGeom prst="rect">
+            <a:avLst/>
+          </a:prstGeom>
+          <a:ln>
+            <a:solidFill>
+              <a:schemeClr val="tx1"/>
+            </a:solidFill>
+          </a:ln>
+        </p:spPr>
+      </p:pic>
+      <p:sp>
+        <p:nvSpPr>
+          <p:cNvPr id="2" name="Заголовок 1">
+            <a:extLst>
+              <a:ext uri="{FF2B5EF4-FFF2-40B4-BE49-F238E27FC236}">
+                <a16:creationId xmlns:a16="http://schemas.microsoft.com/office/drawing/2014/main" id="{BECE1EEF-74D4-FE29-81ED-172CC97249E3}"/>
+              </a:ext>
+            </a:extLst>
+          </p:cNvPr>
+          <p:cNvSpPr>
+            <a:spLocks noGrp="1"/>
+          </p:cNvSpPr>
+          <p:nvPr>
+            <p:ph type="title"/>
+          </p:nvPr>
+        </p:nvSpPr>
+        <p:spPr>
+          <a:xfrm>
+            <a:off x="1143000" y="263770"/>
+            <a:ext cx="9601200" cy="615462"/>
+          </a:xfrm>
+        </p:spPr>
+        <p:txBody>
+          <a:bodyPr>
+            <a:normAutofit/>
+          </a:bodyPr>
+          <a:lstStyle/>
+          <a:p>
+            <a:r>
+              <a:rPr lang="ru-RU" sz="3600" dirty="0"/>
+              <a:t>Пример: Сортировка слиянием</a:t>
+            </a:r>
+          </a:p>
+        </p:txBody>
+      </p:sp>
+    </p:spTree>
+    <p:extLst>
+      <p:ext uri="{BB962C8B-B14F-4D97-AF65-F5344CB8AC3E}">
+        <p14:creationId xmlns:p14="http://schemas.microsoft.com/office/powerpoint/2010/main" val="541210776"/>
+      </p:ext>
+    </p:extLst>
+  </p:cSld>
+  <p:clrMapOvr>
+    <a:masterClrMapping/>
+  </p:clrMapOvr>
+</p:sld>
+</file>
+
+<file path=ppt/slides/slide11.xml><?xml version="1.0" encoding="utf-8"?>
+<p:sld xmlns:a="http://schemas.openxmlformats.org/drawingml/2006/main" xmlns:r="http://schemas.openxmlformats.org/officeDocument/2006/relationships" xmlns:p="http://schemas.openxmlformats.org/presentationml/2006/main">
+  <p:cSld>
+    <p:bg>
+      <p:bgPr>
+        <a:solidFill>
+          <a:schemeClr val="bg1"/>
+        </a:solidFill>
+        <a:effectLst/>
+      </p:bgPr>
+    </p:bg>
+    <p:spTree>
+      <p:nvGrpSpPr>
+        <p:cNvPr id="1" name=""/>
+        <p:cNvGrpSpPr/>
+        <p:nvPr/>
+      </p:nvGrpSpPr>
+      <p:grpSpPr>
+        <a:xfrm>
+          <a:off x="0" y="0"/>
+          <a:ext cx="0" cy="0"/>
+          <a:chOff x="0" y="0"/>
+          <a:chExt cx="0" cy="0"/>
+        </a:xfrm>
+      </p:grpSpPr>
+      <p:sp>
+        <p:nvSpPr>
+          <p:cNvPr id="2" name="Заголовок 1">
+            <a:extLst>
+              <a:ext uri="{FF2B5EF4-FFF2-40B4-BE49-F238E27FC236}">
+                <a16:creationId xmlns:a16="http://schemas.microsoft.com/office/drawing/2014/main" id="{332C0275-5A4C-B45E-B90E-2CE8F1C2F067}"/>
+              </a:ext>
+            </a:extLst>
+          </p:cNvPr>
+          <p:cNvSpPr>
+            <a:spLocks noGrp="1"/>
+          </p:cNvSpPr>
+          <p:nvPr>
+            <p:ph type="title"/>
+          </p:nvPr>
+        </p:nvSpPr>
+        <p:spPr/>
+        <p:txBody>
+          <a:bodyPr/>
+          <a:lstStyle/>
+          <a:p>
+            <a:r>
+              <a:rPr lang="ru-RU" dirty="0"/>
+              <a:t>Преимущества метода</a:t>
+            </a:r>
+          </a:p>
+        </p:txBody>
+      </p:sp>
+      <p:sp>
+        <p:nvSpPr>
+          <p:cNvPr id="3" name="Объект 2">
+            <a:extLst>
+              <a:ext uri="{FF2B5EF4-FFF2-40B4-BE49-F238E27FC236}">
+                <a16:creationId xmlns:a16="http://schemas.microsoft.com/office/drawing/2014/main" id="{911A959B-CFA8-B8D6-DA84-CE6A632E7C16}"/>
+              </a:ext>
+            </a:extLst>
+          </p:cNvPr>
+          <p:cNvSpPr>
+            <a:spLocks noGrp="1"/>
+          </p:cNvSpPr>
+          <p:nvPr>
+            <p:ph idx="1"/>
+          </p:nvPr>
+        </p:nvSpPr>
+        <p:spPr>
+          <a:xfrm>
+            <a:off x="1219200" y="1946031"/>
+            <a:ext cx="9601200" cy="3581400"/>
+          </a:xfrm>
+        </p:spPr>
+        <p:txBody>
+          <a:bodyPr/>
+          <a:lstStyle/>
+          <a:p>
+            <a:r>
+              <a:rPr lang="ru-RU" sz="2800" b="0" i="0" dirty="0">
+                <a:effectLst/>
+              </a:rPr>
+              <a:t>Метод позволяет перейти от неэффективных обычных решений к более быстрым;</a:t>
+            </a:r>
+          </a:p>
+          <a:p>
+            <a:r>
+              <a:rPr lang="ru-RU" sz="2800" b="0" i="0" dirty="0">
+                <a:solidFill>
+                  <a:srgbClr val="0F1115"/>
+                </a:solidFill>
+                <a:effectLst/>
+              </a:rPr>
+              <a:t>Подзадачи </a:t>
+            </a:r>
+            <a:r>
+              <a:rPr lang="ru-RU" sz="2800" i="0" dirty="0">
+                <a:solidFill>
+                  <a:srgbClr val="0F1115"/>
+                </a:solidFill>
+                <a:effectLst/>
+              </a:rPr>
+              <a:t>независимы</a:t>
+            </a:r>
+            <a:r>
+              <a:rPr lang="ru-RU" sz="2800" b="0" i="0" dirty="0">
+                <a:solidFill>
+                  <a:srgbClr val="0F1115"/>
+                </a:solidFill>
+                <a:effectLst/>
+              </a:rPr>
+              <a:t> друг от друга;</a:t>
+            </a:r>
+          </a:p>
+          <a:p>
+            <a:r>
+              <a:rPr lang="ru-RU" sz="2800" b="0" i="0" dirty="0">
+                <a:solidFill>
+                  <a:srgbClr val="0F1115"/>
+                </a:solidFill>
+                <a:effectLst/>
+              </a:rPr>
+              <a:t>Сложные задачи, которые трудно решить целиком, становятся управляемыми при разбиении на простые подзадачи.</a:t>
+            </a:r>
+          </a:p>
+          <a:p>
+            <a:endParaRPr lang="ru-RU" b="0" i="0" dirty="0">
+              <a:solidFill>
+                <a:srgbClr val="0F1115"/>
+              </a:solidFill>
+              <a:effectLst/>
+              <a:latin typeface="quote-cjk-patch"/>
+            </a:endParaRPr>
+          </a:p>
+          <a:p>
+            <a:endParaRPr lang="ru-RU" dirty="0"/>
+          </a:p>
+        </p:txBody>
+      </p:sp>
+    </p:spTree>
+    <p:extLst>
+      <p:ext uri="{BB962C8B-B14F-4D97-AF65-F5344CB8AC3E}">
+        <p14:creationId xmlns:p14="http://schemas.microsoft.com/office/powerpoint/2010/main" val="1494097913"/>
+      </p:ext>
+    </p:extLst>
+  </p:cSld>
+  <p:clrMapOvr>
+    <a:masterClrMapping/>
+  </p:clrMapOvr>
+</p:sld>
+</file>
+
+<file path=ppt/slides/slide12.xml><?xml version="1.0" encoding="utf-8"?>
+<p:sld xmlns:a="http://schemas.openxmlformats.org/drawingml/2006/main" xmlns:r="http://schemas.openxmlformats.org/officeDocument/2006/relationships" xmlns:p="http://schemas.openxmlformats.org/presentationml/2006/main">
+  <p:cSld>
+    <p:bg>
+      <p:bgPr>
+        <a:solidFill>
+          <a:schemeClr val="bg1"/>
+        </a:solidFill>
+        <a:effectLst/>
+      </p:bgPr>
+    </p:bg>
+    <p:spTree>
+      <p:nvGrpSpPr>
+        <p:cNvPr id="1" name=""/>
+        <p:cNvGrpSpPr/>
+        <p:nvPr/>
+      </p:nvGrpSpPr>
+      <p:grpSpPr>
+        <a:xfrm>
+          <a:off x="0" y="0"/>
+          <a:ext cx="0" cy="0"/>
+          <a:chOff x="0" y="0"/>
+          <a:chExt cx="0" cy="0"/>
+        </a:xfrm>
+      </p:grpSpPr>
+      <p:sp>
+        <p:nvSpPr>
+          <p:cNvPr id="4" name="Заголовок 1">
+            <a:extLst>
+              <a:ext uri="{FF2B5EF4-FFF2-40B4-BE49-F238E27FC236}">
+                <a16:creationId xmlns:a16="http://schemas.microsoft.com/office/drawing/2014/main" id="{9BDCE925-3A0C-60B7-50F3-B0F5D1485EA2}"/>
+              </a:ext>
+            </a:extLst>
+          </p:cNvPr>
+          <p:cNvSpPr>
+            <a:spLocks noGrp="1"/>
+          </p:cNvSpPr>
+          <p:nvPr>
+            <p:ph type="title"/>
+          </p:nvPr>
+        </p:nvSpPr>
+        <p:spPr>
+          <a:xfrm>
+            <a:off x="2929890" y="2954601"/>
+            <a:ext cx="6332220" cy="695379"/>
+          </a:xfrm>
+        </p:spPr>
+        <p:txBody>
+          <a:bodyPr/>
+          <a:lstStyle/>
+          <a:p>
+            <a:r>
+              <a:rPr lang="ru-RU" dirty="0"/>
+              <a:t>Спасибо за внимание!</a:t>
+            </a:r>
+          </a:p>
+        </p:txBody>
+      </p:sp>
+    </p:spTree>
+    <p:extLst>
+      <p:ext uri="{BB962C8B-B14F-4D97-AF65-F5344CB8AC3E}">
+        <p14:creationId xmlns:p14="http://schemas.microsoft.com/office/powerpoint/2010/main" val="2429250927"/>
+      </p:ext>
+    </p:extLst>
+  </p:cSld>
+  <p:clrMapOvr>
+    <a:masterClrMapping/>
+  </p:clrMapOvr>
+</p:sld>
+</file>
+
 <file path=ppt/slides/slide2.xml><?xml version="1.0" encoding="utf-8"?>
 <p:sld xmlns:a="http://schemas.openxmlformats.org/drawingml/2006/main" xmlns:r="http://schemas.openxmlformats.org/officeDocument/2006/relationships" xmlns:p="http://schemas.openxmlformats.org/presentationml/2006/main">
   <p:cSld>
@@ -6460,8 +6794,8 @@
         </p:nvSpPr>
         <p:spPr>
           <a:xfrm>
-            <a:off x="1744579" y="1690436"/>
-            <a:ext cx="8963526" cy="3416320"/>
+            <a:off x="1582615" y="1684574"/>
+            <a:ext cx="9500628" cy="4031873"/>
           </a:xfrm>
           <a:prstGeom prst="rect">
             <a:avLst/>
@@ -6475,21 +6809,21 @@
           <a:lstStyle/>
           <a:p>
             <a:pPr marL="342900" indent="-342900">
-              <a:buFont typeface="+mj-lt"/>
-              <a:buAutoNum type="arabicPeriod"/>
+              <a:buFont typeface="Arial" panose="020B0604020202020204" pitchFamily="34" charset="0"/>
+              <a:buChar char="•"/>
             </a:pPr>
             <a:r>
-              <a:rPr lang="ru-RU" b="1" i="0" dirty="0">
+              <a:rPr lang="ru-RU" sz="2000" b="1" i="0" dirty="0">
                 <a:effectLst/>
               </a:rPr>
               <a:t>Сортировка слиянием </a:t>
             </a:r>
             <a:r>
-              <a:rPr lang="ru-RU" dirty="0"/>
+              <a:rPr lang="ru-RU" sz="2000" dirty="0"/>
               <a:t>- </a:t>
             </a:r>
             <a:r>
-              <a:rPr lang="ru-RU" b="0" i="0" dirty="0">
+              <a:rPr lang="ru-RU" sz="2000" b="0" i="0" dirty="0">
                 <a:effectLst/>
               </a:rPr>
               <a:t>делит массив пополам, рекурсивно сортирует каждую половину и сливает два отсортированных массива в один.</a:t>
@@ -6497,17 +6831,17 @@
           </a:p>
           <a:p>
             <a:pPr marL="342900" indent="-342900">
-              <a:buFont typeface="+mj-lt"/>
-              <a:buAutoNum type="arabicPeriod"/>
+              <a:buFont typeface="Arial" panose="020B0604020202020204" pitchFamily="34" charset="0"/>
+              <a:buChar char="•"/>
             </a:pPr>
             <a:r>
-              <a:rPr lang="ru-RU" b="1" i="0" dirty="0">
+              <a:rPr lang="ru-RU" sz="2000" b="1" i="0" dirty="0">
                 <a:effectLst/>
               </a:rPr>
               <a:t>Быстрая сортировка </a:t>
             </a:r>
             <a:r>
-              <a:rPr lang="ru-RU" b="0" i="0" dirty="0">
+              <a:rPr lang="ru-RU" sz="2000" b="0" i="0" dirty="0">
                 <a:effectLst/>
               </a:rPr>
               <a:t>- выбирает опорный элемент, разделяет массив на элементы меньше и больше опорного, затем рекурсивно сортирует части.</a:t>
@@ -6515,20 +6849,11 @@
           </a:p>
           <a:p>
             <a:pPr marL="342900" indent="-342900">
-              <a:buFont typeface="+mj-lt"/>
-              <a:buAutoNum type="arabicPeriod"/>
+              <a:buFont typeface="Arial" panose="020B0604020202020204" pitchFamily="34" charset="0"/>
+              <a:buChar char="•"/>
             </a:pPr>
-            <a:endParaRPr lang="ru-RU" b="0" i="0" dirty="0">
-              <a:effectLst/>
-            </a:endParaRPr>
-          </a:p>
-          <a:p>
-            <a:pPr marL="342900" indent="-342900">
-              <a:buFont typeface="+mj-lt"/>
-              <a:buAutoNum type="arabicPeriod"/>
-            </a:pPr>
-            <a:r>
-              <a:rPr lang="ru-RU" b="1" i="0" dirty="0">
+            <a:r>
+              <a:rPr lang="ru-RU" sz="2000" b="1" i="0" dirty="0">
                 <a:solidFill>
                   <a:srgbClr val="181818"/>
                 </a:solidFill>
@@ -6537,7 +6862,7 @@
               <a:t>Бинарный поиск </a:t>
             </a:r>
             <a:r>
-              <a:rPr lang="ru-RU" b="0" i="0" dirty="0">
+              <a:rPr lang="ru-RU" sz="2000" b="0" i="0" dirty="0">
                 <a:solidFill>
                   <a:srgbClr val="181818"/>
                 </a:solidFill>
@@ -6548,39 +6873,39 @@
           </a:p>
           <a:p>
             <a:pPr marL="342900" indent="-342900">
-              <a:buFont typeface="+mj-lt"/>
-              <a:buAutoNum type="arabicPeriod"/>
+              <a:buFont typeface="Arial" panose="020B0604020202020204" pitchFamily="34" charset="0"/>
+              <a:buChar char="•"/>
             </a:pPr>
             <a:r>
-              <a:rPr lang="ru-RU" b="1" i="0" dirty="0">
+              <a:rPr lang="ru-RU" sz="2000" b="1" i="0" dirty="0">
                 <a:effectLst/>
               </a:rPr>
               <a:t>Алгоритм </a:t>
             </a:r>
             <a:r>
-              <a:rPr lang="ru-RU" b="1" i="0" dirty="0" err="1">
+              <a:rPr lang="ru-RU" sz="2000" b="1" i="0" dirty="0" err="1">
                 <a:effectLst/>
               </a:rPr>
               <a:t>Карацубы</a:t>
             </a:r>
             <a:r>
-              <a:rPr lang="ru-RU" b="1" i="0" dirty="0">
+              <a:rPr lang="ru-RU" sz="2000" b="1" i="0" dirty="0">
                 <a:effectLst/>
               </a:rPr>
               <a:t> </a:t>
             </a:r>
             <a:r>
-              <a:rPr lang="en-US" dirty="0"/>
+              <a:rPr lang="en-US" sz="2000" dirty="0"/>
               <a:t>-</a:t>
             </a:r>
             <a:r>
-              <a:rPr lang="ru-RU" b="0" i="0" dirty="0">
+              <a:rPr lang="ru-RU" sz="2000" b="0" i="0" dirty="0">
                 <a:effectLst/>
               </a:rPr>
               <a:t> умножение больших чисел за </a:t>
             </a:r>
             <a:r>
-              <a:rPr lang="en-US" sz="1800" kern="100" dirty="0">
+              <a:rPr lang="en-US" sz="2000" kern="100" dirty="0">
                 <a:effectLst/>
                 <a:ea typeface="Aptos" panose="020B0004020202020204" pitchFamily="34" charset="0"/>
                 <a:cs typeface="Times New Roman" panose="02020603050405020304" pitchFamily="18" charset="0"/>
@@ -6588,7 +6913,7 @@
               <a:t>O(n </a:t>
             </a:r>
             <a:r>
-              <a:rPr lang="ru-RU" sz="1800" kern="100" baseline="30000" dirty="0" err="1">
+              <a:rPr lang="ru-RU" sz="2000" kern="100" baseline="30000" dirty="0" err="1">
                 <a:effectLst/>
                 <a:ea typeface="Aptos" panose="020B0004020202020204" pitchFamily="34" charset="0"/>
                 <a:cs typeface="Times New Roman" panose="02020603050405020304" pitchFamily="18" charset="0"/>
@@ -6596,7 +6921,7 @@
               <a:t>log</a:t>
             </a:r>
             <a:r>
-              <a:rPr lang="en-US" sz="1800" kern="100" baseline="30000" dirty="0">
+              <a:rPr lang="en-US" sz="2000" kern="100" baseline="30000" dirty="0">
                 <a:effectLst/>
                 <a:ea typeface="Aptos" panose="020B0004020202020204" pitchFamily="34" charset="0"/>
                 <a:cs typeface="Times New Roman" panose="02020603050405020304" pitchFamily="18" charset="0"/>
@@ -6604,7 +6929,7 @@
               <a:t>_</a:t>
             </a:r>
             <a:r>
-              <a:rPr lang="ru-RU" sz="1800" kern="100" baseline="30000" dirty="0">
+              <a:rPr lang="ru-RU" sz="2000" kern="100" baseline="30000" dirty="0">
                 <a:effectLst/>
                 <a:ea typeface="Aptos" panose="020B0004020202020204" pitchFamily="34" charset="0"/>
                 <a:cs typeface="Times New Roman" panose="02020603050405020304" pitchFamily="18" charset="0"/>
@@ -6612,7 +6937,7 @@
               <a:t>2</a:t>
             </a:r>
             <a:r>
-              <a:rPr lang="en-US" sz="1800" kern="100" baseline="30000" dirty="0">
+              <a:rPr lang="en-US" sz="2000" kern="100" baseline="30000" dirty="0">
                 <a:effectLst/>
                 <a:ea typeface="Aptos" panose="020B0004020202020204" pitchFamily="34" charset="0"/>
                 <a:cs typeface="Times New Roman" panose="02020603050405020304" pitchFamily="18" charset="0"/>
@@ -6620,7 +6945,7 @@
               <a:t>(</a:t>
             </a:r>
             <a:r>
-              <a:rPr lang="ru-RU" sz="1800" kern="100" baseline="30000" dirty="0">
+              <a:rPr lang="ru-RU" sz="2000" kern="100" baseline="30000" dirty="0">
                 <a:effectLst/>
                 <a:ea typeface="Aptos" panose="020B0004020202020204" pitchFamily="34" charset="0"/>
                 <a:cs typeface="Times New Roman" panose="02020603050405020304" pitchFamily="18" charset="0"/>
@@ -6628,7 +6953,7 @@
               <a:t>3</a:t>
             </a:r>
             <a:r>
-              <a:rPr lang="en-US" sz="1800" kern="100" baseline="30000" dirty="0">
+              <a:rPr lang="en-US" sz="2000" kern="100" baseline="30000" dirty="0">
                 <a:effectLst/>
                 <a:ea typeface="Aptos" panose="020B0004020202020204" pitchFamily="34" charset="0"/>
                 <a:cs typeface="Times New Roman" panose="02020603050405020304" pitchFamily="18" charset="0"/>
@@ -6636,7 +6961,7 @@
               <a:t>)</a:t>
             </a:r>
             <a:r>
-              <a:rPr lang="en-US" sz="1800" kern="100" dirty="0">
+              <a:rPr lang="en-US" sz="2000" kern="100" dirty="0">
                 <a:effectLst/>
                 <a:ea typeface="Aptos" panose="020B0004020202020204" pitchFamily="34" charset="0"/>
                 <a:cs typeface="Times New Roman" panose="02020603050405020304" pitchFamily="18" charset="0"/>
@@ -6644,20 +6969,20 @@
               <a:t>)</a:t>
             </a:r>
             <a:r>
-              <a:rPr lang="en-US" kern="100" dirty="0">
+              <a:rPr lang="en-US" sz="2000" kern="100" dirty="0">
                 <a:ea typeface="Aptos" panose="020B0004020202020204" pitchFamily="34" charset="0"/>
                 <a:cs typeface="Times New Roman" panose="02020603050405020304" pitchFamily="18" charset="0"/>
               </a:rPr>
               <a:t> </a:t>
             </a:r>
             <a:r>
-              <a:rPr lang="ru-RU" b="0" i="0" dirty="0">
+              <a:rPr lang="ru-RU" sz="2000" b="0" i="0" dirty="0">
                 <a:effectLst/>
               </a:rPr>
               <a:t>вместо классического </a:t>
             </a:r>
             <a:r>
-              <a:rPr lang="ru-RU" sz="1800" dirty="0">
+              <a:rPr lang="ru-RU" sz="2000" dirty="0">
                 <a:effectLst/>
                 <a:ea typeface="Aptos" panose="020B0004020202020204" pitchFamily="34" charset="0"/>
                 <a:cs typeface="Times New Roman" panose="02020603050405020304" pitchFamily="18" charset="0"/>
@@ -6665,7 +6990,7 @@
               <a:t>O(n</a:t>
             </a:r>
             <a:r>
-              <a:rPr lang="ru-RU" sz="1800" baseline="30000" dirty="0">
+              <a:rPr lang="ru-RU" sz="2000" baseline="30000" dirty="0">
                 <a:effectLst/>
                 <a:ea typeface="Aptos" panose="020B0004020202020204" pitchFamily="34" charset="0"/>
                 <a:cs typeface="Times New Roman" panose="02020603050405020304" pitchFamily="18" charset="0"/>
@@ -6673,7 +6998,7 @@
               <a:t>2</a:t>
             </a:r>
             <a:r>
-              <a:rPr lang="ru-RU" sz="1800" dirty="0">
+              <a:rPr lang="ru-RU" sz="2000" dirty="0">
                 <a:effectLst/>
                 <a:ea typeface="Aptos" panose="020B0004020202020204" pitchFamily="34" charset="0"/>
                 <a:cs typeface="Times New Roman" panose="02020603050405020304" pitchFamily="18" charset="0"/>
@@ -6681,11 +7006,44 @@
               <a:t>) </a:t>
             </a:r>
             <a:r>
-              <a:rPr lang="ru-RU" b="0" i="0" dirty="0">
+              <a:rPr lang="ru-RU" sz="2000" b="0" i="0" dirty="0">
                 <a:effectLst/>
               </a:rPr>
               <a:t>за счёт разбиения на части и уменьшения количества перемножений.</a:t>
             </a:r>
+          </a:p>
+          <a:p>
+            <a:pPr marL="342900" indent="-342900">
+              <a:buFont typeface="Arial" panose="020B0604020202020204" pitchFamily="34" charset="0"/>
+              <a:buChar char="•"/>
+            </a:pPr>
+            <a:r>
+              <a:rPr lang="ru-RU" sz="2000" b="1" dirty="0"/>
+              <a:t>Алгоритм </a:t>
+            </a:r>
+            <a:r>
+              <a:rPr lang="ru-RU" sz="2000" b="1" dirty="0" err="1"/>
+              <a:t>Штрассена</a:t>
+            </a:r>
+            <a:r>
+              <a:rPr lang="ru-RU" sz="2000" b="1" dirty="0"/>
+              <a:t> </a:t>
+            </a:r>
+            <a:r>
+              <a:rPr lang="ru-RU" sz="2000" dirty="0"/>
+              <a:t>– алгоритм быстрого умножения квадратных матриц, является обобщением метода умножения </a:t>
+            </a:r>
+            <a:r>
+              <a:rPr lang="ru-RU" sz="2000" dirty="0" err="1"/>
+              <a:t>Карацубы</a:t>
+            </a:r>
+            <a:r>
+              <a:rPr lang="ru-RU" sz="2000" dirty="0"/>
+              <a:t> на матрицы.</a:t>
+            </a:r>
+            <a:endParaRPr lang="ru-RU" sz="2000" b="0" i="0" dirty="0">
+              <a:effectLst/>
+            </a:endParaRPr>
           </a:p>
           <a:p>
             <a:pPr marL="342900" indent="-342900">
@@ -6744,12 +7102,74 @@
           <a:chExt cx="0" cy="0"/>
         </a:xfrm>
       </p:grpSpPr>
+      <p:sp>
+        <p:nvSpPr>
+          <p:cNvPr id="3" name="Объект 2">
+            <a:extLst>
+              <a:ext uri="{FF2B5EF4-FFF2-40B4-BE49-F238E27FC236}">
+                <a16:creationId xmlns:a16="http://schemas.microsoft.com/office/drawing/2014/main" id="{0DC1C07A-80E0-B937-3CDB-E61492C48EB2}"/>
+              </a:ext>
+            </a:extLst>
+          </p:cNvPr>
+          <p:cNvSpPr>
+            <a:spLocks noGrp="1"/>
+          </p:cNvSpPr>
+          <p:nvPr>
+            <p:ph idx="1"/>
+          </p:nvPr>
+        </p:nvSpPr>
+        <p:spPr>
+          <a:xfrm>
+            <a:off x="1161048" y="445169"/>
+            <a:ext cx="9601200" cy="1225369"/>
+          </a:xfrm>
+        </p:spPr>
+        <p:txBody>
+          <a:bodyPr/>
+          <a:lstStyle/>
+          <a:p>
+            <a:pPr marL="0" indent="0">
+              <a:buNone/>
+            </a:pPr>
+            <a:r>
+              <a:rPr lang="ru-RU" dirty="0"/>
+              <a:t>Математически работа алгоритмов </a:t>
+            </a:r>
+            <a:r>
+              <a:rPr lang="en-US" dirty="0"/>
+              <a:t>“</a:t>
+            </a:r>
+            <a:r>
+              <a:rPr lang="ru-RU" dirty="0"/>
+              <a:t>разделяй и властвуй</a:t>
+            </a:r>
+            <a:r>
+              <a:rPr lang="en-US" dirty="0"/>
+              <a:t>”</a:t>
+            </a:r>
+            <a:r>
+              <a:rPr lang="ru-RU" dirty="0"/>
+              <a:t> описывается с помощью рекуррентного соотношения. Чаще всего используется формула, которая легла в основу Основной теоремы о рекуррентных соотношениях</a:t>
+            </a:r>
+            <a:r>
+              <a:rPr lang="en-US" dirty="0"/>
+              <a:t>:</a:t>
+            </a:r>
+          </a:p>
+          <a:p>
+            <a:pPr marL="0" indent="0">
+              <a:buNone/>
+            </a:pPr>
+            <a:endParaRPr lang="ru-RU" dirty="0"/>
+          </a:p>
+        </p:txBody>
+      </p:sp>
       <p:pic>
         <p:nvPicPr>
           <p:cNvPr id="5" name="Рисунок 4">
             <a:extLst>
               <a:ext uri="{FF2B5EF4-FFF2-40B4-BE49-F238E27FC236}">
-                <a16:creationId xmlns:a16="http://schemas.microsoft.com/office/drawing/2014/main" id="{479EB046-F122-4400-FBF1-534468400E34}"/>
+                <a16:creationId xmlns:a16="http://schemas.microsoft.com/office/drawing/2014/main" id="{0DC24888-6809-B90E-CA48-DFC470AFAEF2}"/>
               </a:ext>
             </a:extLst>
           </p:cNvPr>
@@ -6760,63 +7180,53 @@
         </p:nvPicPr>
         <p:blipFill>
           <a:blip r:embed="rId2"/>
-          <a:srcRect t="6316"/>
+          <a:srcRect t="5287" b="10317"/>
           <a:stretch/>
         </p:blipFill>
         <p:spPr>
           <a:xfrm>
-            <a:off x="968908" y="1087623"/>
-            <a:ext cx="10254184" cy="5690938"/>
+            <a:off x="3238500" y="1781677"/>
+            <a:ext cx="6629400" cy="908384"/>
           </a:xfrm>
           <a:prstGeom prst="rect">
             <a:avLst/>
           </a:prstGeom>
-          <a:ln>
-            <a:solidFill>
-              <a:schemeClr val="tx1"/>
-            </a:solidFill>
-          </a:ln>
         </p:spPr>
       </p:pic>
-      <p:sp>
-        <p:nvSpPr>
-          <p:cNvPr id="2" name="Заголовок 1">
+      <p:pic>
+        <p:nvPicPr>
+          <p:cNvPr id="7" name="Рисунок 6">
             <a:extLst>
               <a:ext uri="{FF2B5EF4-FFF2-40B4-BE49-F238E27FC236}">
-                <a16:creationId xmlns:a16="http://schemas.microsoft.com/office/drawing/2014/main" id="{BECE1EEF-74D4-FE29-81ED-172CC97249E3}"/>
+                <a16:creationId xmlns:a16="http://schemas.microsoft.com/office/drawing/2014/main" id="{62226066-8C5B-059F-05EE-5EC0BCBB4450}"/>
               </a:ext>
             </a:extLst>
           </p:cNvPr>
-          <p:cNvSpPr>
-            <a:spLocks noGrp="1"/>
-          </p:cNvSpPr>
-          <p:nvPr>
-            <p:ph type="title"/>
-          </p:nvPr>
-        </p:nvSpPr>
-        <p:spPr>
-          <a:xfrm>
-            <a:off x="1143000" y="263770"/>
-            <a:ext cx="9601200" cy="615462"/>
-          </a:xfrm>
-        </p:spPr>
-        <p:txBody>
-          <a:bodyPr>
-            <a:normAutofit/>
-          </a:bodyPr>
-          <a:lstStyle/>
-          <a:p>
-            <a:r>
-              <a:rPr lang="ru-RU" sz="3600" dirty="0"/>
-              <a:t>Пример: Сортировка слиянием</a:t>
-            </a:r>
-          </a:p>
-        </p:txBody>
-      </p:sp>
+          <p:cNvPicPr>
+            <a:picLocks noChangeAspect="1"/>
+          </p:cNvPicPr>
+          <p:nvPr/>
+        </p:nvPicPr>
+        <p:blipFill>
+          <a:blip r:embed="rId3"/>
+          <a:stretch>
+            <a:fillRect/>
+          </a:stretch>
+        </p:blipFill>
+        <p:spPr>
+          <a:xfrm>
+            <a:off x="3080853" y="2915177"/>
+            <a:ext cx="6944694" cy="3229426"/>
+          </a:xfrm>
+          <a:prstGeom prst="rect">
+            <a:avLst/>
+          </a:prstGeom>
+        </p:spPr>
+      </p:pic>
     </p:spTree>
     <p:extLst>
       <p:ext uri="{BB962C8B-B14F-4D97-AF65-F5344CB8AC3E}">
-        <p14:creationId xmlns:p14="http://schemas.microsoft.com/office/powerpoint/2010/main" val="541210776"/>
+        <p14:creationId xmlns:p14="http://schemas.microsoft.com/office/powerpoint/2010/main" val="4287118701"/>
       </p:ext>
     </p:extLst>
   </p:cSld>
@@ -6962,74 +7372,12 @@
           <a:chExt cx="0" cy="0"/>
         </a:xfrm>
       </p:grpSpPr>
-      <p:sp>
-        <p:nvSpPr>
-          <p:cNvPr id="3" name="Объект 2">
+      <p:pic>
+        <p:nvPicPr>
+          <p:cNvPr id="8" name="Рисунок 7">
             <a:extLst>
               <a:ext uri="{FF2B5EF4-FFF2-40B4-BE49-F238E27FC236}">
-                <a16:creationId xmlns:a16="http://schemas.microsoft.com/office/drawing/2014/main" id="{0DC1C07A-80E0-B937-3CDB-E61492C48EB2}"/>
-              </a:ext>
-            </a:extLst>
-          </p:cNvPr>
-          <p:cNvSpPr>
-            <a:spLocks noGrp="1"/>
-          </p:cNvSpPr>
-          <p:nvPr>
-            <p:ph idx="1"/>
-          </p:nvPr>
-        </p:nvSpPr>
-        <p:spPr>
-          <a:xfrm>
-            <a:off x="1161048" y="445169"/>
-            <a:ext cx="9601200" cy="3581400"/>
-          </a:xfrm>
-        </p:spPr>
-        <p:txBody>
-          <a:bodyPr/>
-          <a:lstStyle/>
-          <a:p>
-            <a:pPr marL="0" indent="0">
-              <a:buNone/>
-            </a:pPr>
-            <a:r>
-              <a:rPr lang="ru-RU" dirty="0"/>
-              <a:t>Математически работа алгоритмов </a:t>
-            </a:r>
-            <a:r>
-              <a:rPr lang="en-US" dirty="0"/>
-              <a:t>“</a:t>
-            </a:r>
-            <a:r>
-              <a:rPr lang="ru-RU" dirty="0"/>
-              <a:t>разделяй и властвуй</a:t>
-            </a:r>
-            <a:r>
-              <a:rPr lang="en-US" dirty="0"/>
-              <a:t>”</a:t>
-            </a:r>
-            <a:r>
-              <a:rPr lang="ru-RU" dirty="0"/>
-              <a:t> описывается с помощью рекуррентного соотношения. Чаще всего используется формула, которая легла в основу Основной теоремы о рекуррентных соотношениях</a:t>
-            </a:r>
-            <a:r>
-              <a:rPr lang="en-US" dirty="0"/>
-              <a:t>:</a:t>
-            </a:r>
-          </a:p>
-          <a:p>
-            <a:pPr marL="0" indent="0">
-              <a:buNone/>
-            </a:pPr>
-            <a:endParaRPr lang="ru-RU" dirty="0"/>
-          </a:p>
-        </p:txBody>
-      </p:sp>
-      <p:pic>
-        <p:nvPicPr>
-          <p:cNvPr id="5" name="Рисунок 4">
-            <a:extLst>
-              <a:ext uri="{FF2B5EF4-FFF2-40B4-BE49-F238E27FC236}">
-                <a16:creationId xmlns:a16="http://schemas.microsoft.com/office/drawing/2014/main" id="{0DC24888-6809-B90E-CA48-DFC470AFAEF2}"/>
+                <a16:creationId xmlns:a16="http://schemas.microsoft.com/office/drawing/2014/main" id="{06A75020-5C98-12CA-1BC9-47A097447D3B}"/>
               </a:ext>
             </a:extLst>
           </p:cNvPr>
@@ -7040,17 +7388,126 @@
         </p:nvPicPr>
         <p:blipFill>
           <a:blip r:embed="rId2"/>
-          <a:srcRect t="5287" b="10317"/>
-          <a:stretch/>
+          <a:stretch>
+            <a:fillRect/>
+          </a:stretch>
         </p:blipFill>
         <p:spPr>
           <a:xfrm>
-            <a:off x="3238500" y="1781677"/>
-            <a:ext cx="6629400" cy="908384"/>
+            <a:off x="2514692" y="152400"/>
+            <a:ext cx="7162616" cy="6553200"/>
           </a:xfrm>
           <a:prstGeom prst="rect">
             <a:avLst/>
           </a:prstGeom>
+        </p:spPr>
+      </p:pic>
+    </p:spTree>
+    <p:extLst>
+      <p:ext uri="{BB962C8B-B14F-4D97-AF65-F5344CB8AC3E}">
+        <p14:creationId xmlns:p14="http://schemas.microsoft.com/office/powerpoint/2010/main" val="2264976180"/>
+      </p:ext>
+    </p:extLst>
+  </p:cSld>
+  <p:clrMapOvr>
+    <a:masterClrMapping/>
+  </p:clrMapOvr>
+</p:sld>
+</file>
+
+<file path=ppt/slides/slide8.xml><?xml version="1.0" encoding="utf-8"?>
+<p:sld xmlns:a="http://schemas.openxmlformats.org/drawingml/2006/main" xmlns:r="http://schemas.openxmlformats.org/officeDocument/2006/relationships" xmlns:p="http://schemas.openxmlformats.org/presentationml/2006/main">
+  <p:cSld>
+    <p:bg>
+      <p:bgPr>
+        <a:solidFill>
+          <a:schemeClr val="bg1"/>
+        </a:solidFill>
+        <a:effectLst/>
+      </p:bgPr>
+    </p:bg>
+    <p:spTree>
+      <p:nvGrpSpPr>
+        <p:cNvPr id="1" name=""/>
+        <p:cNvGrpSpPr/>
+        <p:nvPr/>
+      </p:nvGrpSpPr>
+      <p:grpSpPr>
+        <a:xfrm>
+          <a:off x="0" y="0"/>
+          <a:ext cx="0" cy="0"/>
+          <a:chOff x="0" y="0"/>
+          <a:chExt cx="0" cy="0"/>
+        </a:xfrm>
+      </p:grpSpPr>
+      <p:sp>
+        <p:nvSpPr>
+          <p:cNvPr id="2" name="Заголовок 1">
+            <a:extLst>
+              <a:ext uri="{FF2B5EF4-FFF2-40B4-BE49-F238E27FC236}">
+                <a16:creationId xmlns:a16="http://schemas.microsoft.com/office/drawing/2014/main" id="{07E0421F-7DD9-2A4E-DF16-E9C2EFCE7D4E}"/>
+              </a:ext>
+            </a:extLst>
+          </p:cNvPr>
+          <p:cNvSpPr>
+            <a:spLocks noGrp="1"/>
+          </p:cNvSpPr>
+          <p:nvPr>
+            <p:ph type="title"/>
+          </p:nvPr>
+        </p:nvSpPr>
+        <p:spPr>
+          <a:xfrm>
+            <a:off x="907576" y="255895"/>
+            <a:ext cx="3500301" cy="576618"/>
+          </a:xfrm>
+        </p:spPr>
+        <p:txBody>
+          <a:bodyPr>
+            <a:normAutofit fontScale="90000"/>
+          </a:bodyPr>
+          <a:lstStyle/>
+          <a:p>
+            <a:r>
+              <a:rPr lang="ru-RU" sz="3600" dirty="0"/>
+              <a:t>Оценка сложности</a:t>
+            </a:r>
+          </a:p>
+        </p:txBody>
+      </p:sp>
+      <p:pic>
+        <p:nvPicPr>
+          <p:cNvPr id="5" name="Рисунок 4">
+            <a:extLst>
+              <a:ext uri="{FF2B5EF4-FFF2-40B4-BE49-F238E27FC236}">
+                <a16:creationId xmlns:a16="http://schemas.microsoft.com/office/drawing/2014/main" id="{0D4BBCCE-DD76-8966-0093-762F6E6C426A}"/>
+              </a:ext>
+            </a:extLst>
+          </p:cNvPr>
+          <p:cNvPicPr>
+            <a:picLocks noChangeAspect="1"/>
+          </p:cNvPicPr>
+          <p:nvPr/>
+        </p:nvPicPr>
+        <p:blipFill>
+          <a:blip r:embed="rId2"/>
+          <a:stretch>
+            <a:fillRect/>
+          </a:stretch>
+        </p:blipFill>
+        <p:spPr>
+          <a:xfrm>
+            <a:off x="1084385" y="884291"/>
+            <a:ext cx="2915057" cy="743054"/>
+          </a:xfrm>
+          <a:prstGeom prst="rect">
+            <a:avLst/>
+          </a:prstGeom>
+          <a:ln>
+            <a:solidFill>
+              <a:schemeClr val="tx1"/>
+            </a:solidFill>
+          </a:ln>
         </p:spPr>
       </p:pic>
       <p:pic>
@@ -7058,7 +7515,7 @@
           <p:cNvPr id="7" name="Рисунок 6">
             <a:extLst>
               <a:ext uri="{FF2B5EF4-FFF2-40B4-BE49-F238E27FC236}">
-                <a16:creationId xmlns:a16="http://schemas.microsoft.com/office/drawing/2014/main" id="{62226066-8C5B-059F-05EE-5EC0BCBB4450}"/>
+                <a16:creationId xmlns:a16="http://schemas.microsoft.com/office/drawing/2014/main" id="{30DABE47-216C-61B1-E23B-1BC9518952B4}"/>
               </a:ext>
             </a:extLst>
           </p:cNvPr>
@@ -7075,163 +7532,100 @@
         </p:blipFill>
         <p:spPr>
           <a:xfrm>
-            <a:off x="3080853" y="2915177"/>
-            <a:ext cx="6944694" cy="3229426"/>
+            <a:off x="832339" y="1740933"/>
+            <a:ext cx="5559552" cy="4923635"/>
           </a:xfrm>
           <a:prstGeom prst="rect">
             <a:avLst/>
           </a:prstGeom>
         </p:spPr>
       </p:pic>
+      <p:pic>
+        <p:nvPicPr>
+          <p:cNvPr id="12" name="Рисунок 11">
+            <a:extLst>
+              <a:ext uri="{FF2B5EF4-FFF2-40B4-BE49-F238E27FC236}">
+                <a16:creationId xmlns:a16="http://schemas.microsoft.com/office/drawing/2014/main" id="{AD5C7015-A51D-F91F-BCAB-66AF00F5F18D}"/>
+              </a:ext>
+            </a:extLst>
+          </p:cNvPr>
+          <p:cNvPicPr>
+            <a:picLocks noChangeAspect="1"/>
+          </p:cNvPicPr>
+          <p:nvPr/>
+        </p:nvPicPr>
+        <p:blipFill>
+          <a:blip r:embed="rId4"/>
+          <a:stretch>
+            <a:fillRect/>
+          </a:stretch>
+        </p:blipFill>
+        <p:spPr>
+          <a:xfrm>
+            <a:off x="6820746" y="2186354"/>
+            <a:ext cx="5218833" cy="2343010"/>
+          </a:xfrm>
+          <a:prstGeom prst="rect">
+            <a:avLst/>
+          </a:prstGeom>
+        </p:spPr>
+      </p:pic>
+      <p:sp>
+        <p:nvSpPr>
+          <p:cNvPr id="16" name="Прямоугольник 15">
+            <a:extLst>
+              <a:ext uri="{FF2B5EF4-FFF2-40B4-BE49-F238E27FC236}">
+                <a16:creationId xmlns:a16="http://schemas.microsoft.com/office/drawing/2014/main" id="{67DD7F71-EA4D-8223-77B5-C27EC190AFE6}"/>
+              </a:ext>
+            </a:extLst>
+          </p:cNvPr>
+          <p:cNvSpPr/>
+          <p:nvPr/>
+        </p:nvSpPr>
+        <p:spPr>
+          <a:xfrm>
+            <a:off x="6643937" y="0"/>
+            <a:ext cx="88404" cy="6858000"/>
+          </a:xfrm>
+          <a:prstGeom prst="rect">
+            <a:avLst/>
+          </a:prstGeom>
+          <a:solidFill>
+            <a:schemeClr val="tx1"/>
+          </a:solidFill>
+          <a:ln>
+            <a:noFill/>
+          </a:ln>
+        </p:spPr>
+        <p:style>
+          <a:lnRef idx="2">
+            <a:schemeClr val="accent1">
+              <a:shade val="15000"/>
+            </a:schemeClr>
+          </a:lnRef>
+          <a:fillRef idx="1">
+            <a:schemeClr val="accent1"/>
+          </a:fillRef>
+          <a:effectRef idx="0">
+            <a:schemeClr val="accent1"/>
+          </a:effectRef>
+          <a:fontRef idx="minor">
+            <a:schemeClr val="lt1"/>
+          </a:fontRef>
+        </p:style>
+        <p:txBody>
+          <a:bodyPr rtlCol="0" anchor="ctr"/>
+          <a:lstStyle/>
+          <a:p>
+            <a:pPr algn="ctr"/>
+            <a:endParaRPr lang="ru-RU"/>
+          </a:p>
+        </p:txBody>
+      </p:sp>
     </p:spTree>
     <p:extLst>
       <p:ext uri="{BB962C8B-B14F-4D97-AF65-F5344CB8AC3E}">
-        <p14:creationId xmlns:p14="http://schemas.microsoft.com/office/powerpoint/2010/main" val="4287118701"/>
-      </p:ext>
-    </p:extLst>
-  </p:cSld>
-  <p:clrMapOvr>
-    <a:masterClrMapping/>
-  </p:clrMapOvr>
-</p:sld>
-</file>
-
-<file path=ppt/slides/slide8.xml><?xml version="1.0" encoding="utf-8"?>
-<p:sld xmlns:a="http://schemas.openxmlformats.org/drawingml/2006/main" xmlns:r="http://schemas.openxmlformats.org/officeDocument/2006/relationships" xmlns:p="http://schemas.openxmlformats.org/presentationml/2006/main">
-  <p:cSld>
-    <p:spTree>
-      <p:nvGrpSpPr>
-        <p:cNvPr id="1" name=""/>
-        <p:cNvGrpSpPr/>
-        <p:nvPr/>
-      </p:nvGrpSpPr>
-      <p:grpSpPr>
-        <a:xfrm>
-          <a:off x="0" y="0"/>
-          <a:ext cx="0" cy="0"/>
-          <a:chOff x="0" y="0"/>
-          <a:chExt cx="0" cy="0"/>
-        </a:xfrm>
-      </p:grpSpPr>
-      <p:sp>
-        <p:nvSpPr>
-          <p:cNvPr id="2" name="Заголовок 1">
-            <a:extLst>
-              <a:ext uri="{FF2B5EF4-FFF2-40B4-BE49-F238E27FC236}">
-                <a16:creationId xmlns:a16="http://schemas.microsoft.com/office/drawing/2014/main" id="{332C0275-5A4C-B45E-B90E-2CE8F1C2F067}"/>
-              </a:ext>
-            </a:extLst>
-          </p:cNvPr>
-          <p:cNvSpPr>
-            <a:spLocks noGrp="1"/>
-          </p:cNvSpPr>
-          <p:nvPr>
-            <p:ph type="title"/>
-          </p:nvPr>
-        </p:nvSpPr>
-        <p:spPr/>
-        <p:txBody>
-          <a:bodyPr/>
-          <a:lstStyle/>
-          <a:p>
-            <a:r>
-              <a:rPr lang="ru-RU" dirty="0"/>
-              <a:t>Преимущества метода</a:t>
-            </a:r>
-          </a:p>
-        </p:txBody>
-      </p:sp>
-      <p:sp>
-        <p:nvSpPr>
-          <p:cNvPr id="3" name="Объект 2">
-            <a:extLst>
-              <a:ext uri="{FF2B5EF4-FFF2-40B4-BE49-F238E27FC236}">
-                <a16:creationId xmlns:a16="http://schemas.microsoft.com/office/drawing/2014/main" id="{911A959B-CFA8-B8D6-DA84-CE6A632E7C16}"/>
-              </a:ext>
-            </a:extLst>
-          </p:cNvPr>
-          <p:cNvSpPr>
-            <a:spLocks noGrp="1"/>
-          </p:cNvSpPr>
-          <p:nvPr>
-            <p:ph idx="1"/>
-          </p:nvPr>
-        </p:nvSpPr>
-        <p:spPr/>
-        <p:txBody>
-          <a:bodyPr/>
-          <a:lstStyle/>
-          <a:p>
-            <a:r>
-              <a:rPr lang="ru-RU" b="0" i="0" dirty="0">
-                <a:effectLst/>
-                <a:latin typeface="pplxSerif"/>
-              </a:rPr>
-              <a:t>Метод позволяет перейти от неэффективных обычных решений к более быстрым;</a:t>
-            </a:r>
-          </a:p>
-          <a:p>
-            <a:r>
-              <a:rPr lang="ru-RU" b="0" i="0" dirty="0">
-                <a:solidFill>
-                  <a:srgbClr val="0F1115"/>
-                </a:solidFill>
-                <a:effectLst/>
-                <a:latin typeface="quote-cjk-patch"/>
-              </a:rPr>
-              <a:t>Подзадачи </a:t>
-            </a:r>
-            <a:r>
-              <a:rPr lang="ru-RU" i="0" dirty="0">
-                <a:solidFill>
-                  <a:srgbClr val="0F1115"/>
-                </a:solidFill>
-                <a:effectLst/>
-                <a:latin typeface="quote-cjk-patch"/>
-              </a:rPr>
-              <a:t>независимы</a:t>
-            </a:r>
-            <a:r>
-              <a:rPr lang="ru-RU" b="0" i="0" dirty="0">
-                <a:solidFill>
-                  <a:srgbClr val="0F1115"/>
-                </a:solidFill>
-                <a:effectLst/>
-                <a:latin typeface="quote-cjk-patch"/>
-              </a:rPr>
-              <a:t> друг от друга;</a:t>
-            </a:r>
-          </a:p>
-          <a:p>
-            <a:r>
-              <a:rPr lang="ru-RU" b="0" i="0" dirty="0">
-                <a:solidFill>
-                  <a:srgbClr val="0F1115"/>
-                </a:solidFill>
-                <a:effectLst/>
-                <a:latin typeface="quote-cjk-patch"/>
-              </a:rPr>
-              <a:t>Сложные задачи, которые трудно решить целиком, становятся управляемыми при разбиении на простые подзадачи;</a:t>
-            </a:r>
-          </a:p>
-          <a:p>
-            <a:endParaRPr lang="ru-RU" b="0" i="0" dirty="0">
-              <a:solidFill>
-                <a:srgbClr val="0F1115"/>
-              </a:solidFill>
-              <a:effectLst/>
-              <a:latin typeface="quote-cjk-patch"/>
-            </a:endParaRPr>
-          </a:p>
-          <a:p>
-            <a:endParaRPr lang="ru-RU" dirty="0"/>
-          </a:p>
-        </p:txBody>
-      </p:sp>
-    </p:spTree>
-    <p:extLst>
-      <p:ext uri="{BB962C8B-B14F-4D97-AF65-F5344CB8AC3E}">
-        <p14:creationId xmlns:p14="http://schemas.microsoft.com/office/powerpoint/2010/main" val="1494097913"/>
+        <p14:creationId xmlns:p14="http://schemas.microsoft.com/office/powerpoint/2010/main" val="1628927492"/>
       </p:ext>
     </p:extLst>
   </p:cSld>
@@ -7268,10 +7662,10 @@
       </p:grpSpPr>
       <p:sp>
         <p:nvSpPr>
-          <p:cNvPr id="4" name="Заголовок 1">
+          <p:cNvPr id="6" name="Заголовок 1">
             <a:extLst>
               <a:ext uri="{FF2B5EF4-FFF2-40B4-BE49-F238E27FC236}">
-                <a16:creationId xmlns:a16="http://schemas.microsoft.com/office/drawing/2014/main" id="{9BDCE925-3A0C-60B7-50F3-B0F5D1485EA2}"/>
+                <a16:creationId xmlns:a16="http://schemas.microsoft.com/office/drawing/2014/main" id="{E9EA524B-29F6-8245-69AA-75526CCAD616}"/>
               </a:ext>
             </a:extLst>
           </p:cNvPr>
@@ -7284,17 +7678,296 @@
         </p:nvSpPr>
         <p:spPr>
           <a:xfrm>
-            <a:off x="2929890" y="2954601"/>
-            <a:ext cx="6332220" cy="695379"/>
-          </a:xfrm>
-        </p:spPr>
-        <p:txBody>
-          <a:bodyPr/>
+            <a:off x="1143000" y="263770"/>
+            <a:ext cx="9601200" cy="615462"/>
+          </a:xfrm>
+        </p:spPr>
+        <p:txBody>
+          <a:bodyPr>
+            <a:normAutofit/>
+          </a:bodyPr>
           <a:lstStyle/>
           <a:p>
             <a:r>
+              <a:rPr lang="ru-RU" sz="3600" dirty="0"/>
+              <a:t>Пример: Бинарный поиск</a:t>
+            </a:r>
+          </a:p>
+        </p:txBody>
+      </p:sp>
+      <p:sp>
+        <p:nvSpPr>
+          <p:cNvPr id="10" name="TextBox 9">
+            <a:extLst>
+              <a:ext uri="{FF2B5EF4-FFF2-40B4-BE49-F238E27FC236}">
+                <a16:creationId xmlns:a16="http://schemas.microsoft.com/office/drawing/2014/main" id="{31B947CA-9AF1-D15F-CDB8-CC1CF8818550}"/>
+              </a:ext>
+            </a:extLst>
+          </p:cNvPr>
+          <p:cNvSpPr txBox="1"/>
+          <p:nvPr/>
+        </p:nvSpPr>
+        <p:spPr>
+          <a:xfrm>
+            <a:off x="1078523" y="799909"/>
+            <a:ext cx="10515600" cy="2308324"/>
+          </a:xfrm>
+          <a:prstGeom prst="rect">
+            <a:avLst/>
+          </a:prstGeom>
+          <a:noFill/>
+        </p:spPr>
+        <p:txBody>
+          <a:bodyPr wrap="square">
+            <a:spAutoFit/>
+          </a:bodyPr>
+          <a:lstStyle/>
+          <a:p>
+            <a:r>
               <a:rPr lang="ru-RU" dirty="0"/>
-              <a:t>Спасибо за внимание!</a:t>
+              <a:t>1. Сортируем массив данных.</a:t>
+            </a:r>
+          </a:p>
+          <a:p>
+            <a:r>
+              <a:rPr lang="ru-RU" dirty="0"/>
+              <a:t>2. Делим его пополам и находим середину.</a:t>
+            </a:r>
+          </a:p>
+          <a:p>
+            <a:r>
+              <a:rPr lang="ru-RU" dirty="0"/>
+              <a:t>3. Сравниваем срединный элемент с заданным искомым элементом.</a:t>
+            </a:r>
+          </a:p>
+          <a:p>
+            <a:r>
+              <a:rPr lang="ru-RU" dirty="0"/>
+              <a:t>4. Если искомое число больше среднего - продолжаем поиск в правой части массива (если он отсортирован по возрастанию): делим ее пополам, повторяя пункт 3. Если же заданное число меньше - алгоритм продолжит поиск в левой части массива, снова возвращаясь к пункту 3.</a:t>
+            </a:r>
+          </a:p>
+          <a:p>
+            <a:endParaRPr lang="ru-RU" dirty="0"/>
+          </a:p>
+          <a:p>
+            <a:r>
+              <a:rPr lang="ru-RU" dirty="0"/>
+              <a:t>Рекуррентное соотношение: </a:t>
+            </a:r>
+            <a:r>
+              <a:rPr lang="pt-BR" b="0" i="1" dirty="0">
+                <a:solidFill>
+                  <a:srgbClr val="0F1115"/>
+                </a:solidFill>
+                <a:effectLst/>
+              </a:rPr>
+              <a:t>T(n)=T(</a:t>
+            </a:r>
+            <a:r>
+              <a:rPr lang="en-US" i="1" dirty="0">
+                <a:solidFill>
+                  <a:srgbClr val="0F1115"/>
+                </a:solidFill>
+              </a:rPr>
+              <a:t>n/2</a:t>
+            </a:r>
+            <a:r>
+              <a:rPr lang="pt-BR" b="0" i="1" dirty="0">
+                <a:solidFill>
+                  <a:srgbClr val="0F1115"/>
+                </a:solidFill>
+                <a:effectLst/>
+              </a:rPr>
+              <a:t>​)+O(1) =&gt; </a:t>
+            </a:r>
+            <a:r>
+              <a:rPr lang="ru-RU" b="0" i="1" dirty="0">
+                <a:solidFill>
+                  <a:srgbClr val="0F1115"/>
+                </a:solidFill>
+                <a:effectLst/>
+              </a:rPr>
+              <a:t>сложность </a:t>
+            </a:r>
+            <a:r>
+              <a:rPr lang="pt-BR" b="0" i="1" dirty="0">
+                <a:solidFill>
+                  <a:srgbClr val="0F1115"/>
+                </a:solidFill>
+                <a:effectLst/>
+              </a:rPr>
+              <a:t>T(n)=O(log n)</a:t>
+            </a:r>
+            <a:endParaRPr lang="ru-RU" i="1" dirty="0"/>
+          </a:p>
+        </p:txBody>
+      </p:sp>
+      <p:pic>
+        <p:nvPicPr>
+          <p:cNvPr id="2050" name="Picture 2" descr="Image of a graph lightbox">
+            <a:extLst>
+              <a:ext uri="{FF2B5EF4-FFF2-40B4-BE49-F238E27FC236}">
+                <a16:creationId xmlns:a16="http://schemas.microsoft.com/office/drawing/2014/main" id="{ACD54A9F-C69D-8445-968A-7D50BBF2F6BB}"/>
+              </a:ext>
+            </a:extLst>
+          </p:cNvPr>
+          <p:cNvPicPr>
+            <a:picLocks noChangeAspect="1" noChangeArrowheads="1"/>
+          </p:cNvPicPr>
+          <p:nvPr/>
+        </p:nvPicPr>
+        <p:blipFill rotWithShape="1">
+          <a:blip r:embed="rId2">
+            <a:extLst>
+              <a:ext uri="{28A0092B-C50C-407E-A947-70E740481C1C}">
+                <a14:useLocalDpi xmlns:a14="http://schemas.microsoft.com/office/drawing/2010/main" val="0"/>
+              </a:ext>
+            </a:extLst>
+          </a:blip>
+          <a:srcRect t="14890" b="70018"/>
+          <a:stretch/>
+        </p:blipFill>
+        <p:spPr bwMode="auto">
+          <a:xfrm>
+            <a:off x="2911109" y="3552092"/>
+            <a:ext cx="6675156" cy="729955"/>
+          </a:xfrm>
+          <a:prstGeom prst="rect">
+            <a:avLst/>
+          </a:prstGeom>
+          <a:noFill/>
+          <a:extLst>
+            <a:ext uri="{909E8E84-426E-40DD-AFC4-6F175D3DCCD1}">
+              <a14:hiddenFill xmlns:a14="http://schemas.microsoft.com/office/drawing/2010/main">
+                <a:solidFill>
+                  <a:srgbClr val="FFFFFF"/>
+                </a:solidFill>
+              </a14:hiddenFill>
+            </a:ext>
+          </a:extLst>
+        </p:spPr>
+      </p:pic>
+      <p:pic>
+        <p:nvPicPr>
+          <p:cNvPr id="11" name="Picture 2" descr="Image of a graph lightbox">
+            <a:extLst>
+              <a:ext uri="{FF2B5EF4-FFF2-40B4-BE49-F238E27FC236}">
+                <a16:creationId xmlns:a16="http://schemas.microsoft.com/office/drawing/2014/main" id="{9E4986EB-C2A3-23B4-2C67-5F37F77C1603}"/>
+              </a:ext>
+            </a:extLst>
+          </p:cNvPr>
+          <p:cNvPicPr>
+            <a:picLocks noChangeAspect="1" noChangeArrowheads="1"/>
+          </p:cNvPicPr>
+          <p:nvPr/>
+        </p:nvPicPr>
+        <p:blipFill rotWithShape="1">
+          <a:blip r:embed="rId2">
+            <a:extLst>
+              <a:ext uri="{28A0092B-C50C-407E-A947-70E740481C1C}">
+                <a14:useLocalDpi xmlns:a14="http://schemas.microsoft.com/office/drawing/2010/main" val="0"/>
+              </a:ext>
+            </a:extLst>
+          </a:blip>
+          <a:srcRect l="805" t="48232" r="-805" b="36676"/>
+          <a:stretch/>
+        </p:blipFill>
+        <p:spPr bwMode="auto">
+          <a:xfrm>
+            <a:off x="2934555" y="4308231"/>
+            <a:ext cx="6675156" cy="729955"/>
+          </a:xfrm>
+          <a:prstGeom prst="rect">
+            <a:avLst/>
+          </a:prstGeom>
+          <a:noFill/>
+          <a:extLst>
+            <a:ext uri="{909E8E84-426E-40DD-AFC4-6F175D3DCCD1}">
+              <a14:hiddenFill xmlns:a14="http://schemas.microsoft.com/office/drawing/2010/main">
+                <a:solidFill>
+                  <a:srgbClr val="FFFFFF"/>
+                </a:solidFill>
+              </a14:hiddenFill>
+            </a:ext>
+          </a:extLst>
+        </p:spPr>
+      </p:pic>
+      <p:pic>
+        <p:nvPicPr>
+          <p:cNvPr id="12" name="Picture 2" descr="Image of a graph lightbox">
+            <a:extLst>
+              <a:ext uri="{FF2B5EF4-FFF2-40B4-BE49-F238E27FC236}">
+                <a16:creationId xmlns:a16="http://schemas.microsoft.com/office/drawing/2014/main" id="{DBECC444-E05F-FBFE-6E9C-9DF4F753AC12}"/>
+              </a:ext>
+            </a:extLst>
+          </p:cNvPr>
+          <p:cNvPicPr>
+            <a:picLocks noChangeAspect="1" noChangeArrowheads="1"/>
+          </p:cNvPicPr>
+          <p:nvPr/>
+        </p:nvPicPr>
+        <p:blipFill rotWithShape="1">
+          <a:blip r:embed="rId2">
+            <a:extLst>
+              <a:ext uri="{28A0092B-C50C-407E-A947-70E740481C1C}">
+                <a14:useLocalDpi xmlns:a14="http://schemas.microsoft.com/office/drawing/2010/main" val="0"/>
+              </a:ext>
+            </a:extLst>
+          </a:blip>
+          <a:srcRect l="2092" t="80901" r="-2092" b="4007"/>
+          <a:stretch/>
+        </p:blipFill>
+        <p:spPr bwMode="auto">
+          <a:xfrm>
+            <a:off x="3013913" y="5064370"/>
+            <a:ext cx="6675156" cy="729955"/>
+          </a:xfrm>
+          <a:prstGeom prst="rect">
+            <a:avLst/>
+          </a:prstGeom>
+          <a:noFill/>
+          <a:extLst>
+            <a:ext uri="{909E8E84-426E-40DD-AFC4-6F175D3DCCD1}">
+              <a14:hiddenFill xmlns:a14="http://schemas.microsoft.com/office/drawing/2010/main">
+                <a:solidFill>
+                  <a:srgbClr val="FFFFFF"/>
+                </a:solidFill>
+              </a14:hiddenFill>
+            </a:ext>
+          </a:extLst>
+        </p:spPr>
+      </p:pic>
+      <p:sp>
+        <p:nvSpPr>
+          <p:cNvPr id="13" name="TextBox 12">
+            <a:extLst>
+              <a:ext uri="{FF2B5EF4-FFF2-40B4-BE49-F238E27FC236}">
+                <a16:creationId xmlns:a16="http://schemas.microsoft.com/office/drawing/2014/main" id="{27FA8569-9A21-33D1-90A3-22CBDCA3BBEE}"/>
+              </a:ext>
+            </a:extLst>
+          </p:cNvPr>
+          <p:cNvSpPr txBox="1"/>
+          <p:nvPr/>
+        </p:nvSpPr>
+        <p:spPr>
+          <a:xfrm>
+            <a:off x="4331677" y="5873425"/>
+            <a:ext cx="4032001" cy="369332"/>
+          </a:xfrm>
+          <a:prstGeom prst="rect">
+            <a:avLst/>
+          </a:prstGeom>
+          <a:noFill/>
+        </p:spPr>
+        <p:txBody>
+          <a:bodyPr wrap="none" rtlCol="0">
+            <a:spAutoFit/>
+          </a:bodyPr>
+          <a:lstStyle/>
+          <a:p>
+            <a:r>
+              <a:rPr lang="ru-RU" dirty="0"/>
+              <a:t>Поиск 67 в отсортированном массиве</a:t>
             </a:r>
           </a:p>
         </p:txBody>
@@ -7302,7 +7975,7 @@
     </p:spTree>
     <p:extLst>
       <p:ext uri="{BB962C8B-B14F-4D97-AF65-F5344CB8AC3E}">
-        <p14:creationId xmlns:p14="http://schemas.microsoft.com/office/powerpoint/2010/main" val="2429250927"/>
+        <p14:creationId xmlns:p14="http://schemas.microsoft.com/office/powerpoint/2010/main" val="1034855749"/>
       </p:ext>
     </p:extLst>
   </p:cSld>

</xml_diff>